<commit_message>
Remove the public demo instructor login
The instructor side is now shown only with the instructor's own account.
- The demo instructor account is deleted at start-up (also on existing
  databases) and stays reserved; any demo account is still refused every
  instructor write as a second line of defence
- Sign-in page offers one button: Open the student view
- README, render.yaml, How it works, architecture notes, report and
  slides updated; scripts/security_check.py now checks that the retired
  login fails (44 checks, all passing)
</commit_message>
<xml_diff>
--- a/docs/AutoGrader.pptx
+++ b/docs/AutoGrader.pptx
@@ -730,7 +730,7 @@
           <a:lstStyle/>
           <a:p>
             <a:r>
-              <a:t>Security covers both the grader, which runs untrusted student code, and the platform. Repository input is restricted, secrets are redacted before anything reaches a model, and the Docker sandbox is locked down. On the platform side, roles are checked on the server for every instructor action, so a student cannot change any grade, sign-in is throttled against password guessing, and the public demo instructor cannot change anything. We verified these with an automated script of 51 checks.</a:t>
+              <a:t>Security covers both the grader, which runs untrusted student code, and the platform. Repository input is restricted, secrets are redacted before anything reaches a model, and the Docker sandbox is locked down. On the platform side, roles are checked on the server for every instructor action, so a student cannot change any grade, sign-in is throttled against password guessing, and the public demo has only a student login. We verified these with an automated script of 44 checks.</a:t>
             </a:r>
           </a:p>
         </p:txBody>
@@ -7358,7 +7358,7 @@
                           </a:solidFill>
                           <a:latin typeface="Segoe UI"/>
                         </a:rPr>
-                        <a:t>sign-up closed in demo mode; demo instructor read-only on the server</a:t>
+                        <a:t>only a demo student login is public; sign-up closed; demo logins read-only</a:t>
                       </a:r>
                     </a:p>
                   </a:txBody>
@@ -11086,7 +11086,7 @@
                 </a:solidFill>
                 <a:latin typeface="Segoe UI"/>
               </a:rPr>
-              <a:t>Sign in → Instructor view (read-only demo)</a:t>
+              <a:t>Sign in with the instructor account</a:t>
             </a:r>
           </a:p>
         </p:txBody>

</xml_diff>